<commit_message>
Fix .pptx so Microsoft PowerPoint can open it
Root cause: the doughnut chart was emitting an empty <c:legendPos/>
element (no 'val' attribute). python-pptx and LibreOffice tolerate
this, but Microsoft PowerPoint's strict schema validator rejects it,
causing the whole file to fail to open.

Changes:
- Add _force_legend_pos() helper that guarantees every chart legend
  has <c:legendPos val=...> with a valid value.
- Switch doughnut legend from RIGHT to BOTTOM for consistency and
  avoid the fragile python-pptx code path.
- Use XL_MARKER_STYLE.CIRCLE enum instead of raw integer.
- Drop custom data-label font color on the doughnut (leave default
  for maximum PowerPoint compatibility).
</commit_message>
<xml_diff>
--- a/vfs-audit-remediations-exec.pptx
+++ b/vfs-audit-remediations-exec.pptx
@@ -144,11 +144,6 @@
               <a:solidFill>
                 <a:srgbClr val="E60000"/>
               </a:solidFill>
-              <a:ln>
-                <a:solidFill>
-                  <a:srgbClr val="E60000"/>
-                </a:solidFill>
-              </a:ln>
             </c:spPr>
           </c:marker>
           <c:cat>
@@ -228,11 +223,6 @@
               <a:solidFill>
                 <a:srgbClr val="16A34A"/>
               </a:solidFill>
-              <a:ln>
-                <a:solidFill>
-                  <a:srgbClr val="16A34A"/>
-                </a:solidFill>
-              </a:ln>
             </c:spPr>
           </c:marker>
           <c:cat>
@@ -555,11 +545,7 @@
             <a:lstStyle/>
             <a:p>
               <a:pPr>
-                <a:defRPr sz="900" b="1">
-                  <a:solidFill>
-                    <a:srgbClr val="FFFFFF"/>
-                  </a:solidFill>
-                </a:defRPr>
+                <a:defRPr sz="900" b="1"/>
               </a:pPr>
             </a:p>
           </c:txPr>
@@ -576,7 +562,7 @@
       </c:doughnutChart>
     </c:plotArea>
     <c:legend>
-      <c:legendPos/>
+      <c:legendPos val="b"/>
       <c:layout/>
       <c:overlay val="0"/>
       <c:txPr>
@@ -829,7 +815,6 @@
     </c:plotArea>
     <c:legend>
       <c:legendPos val="b"/>
-      <c:overlay val="0"/>
       <c:txPr>
         <a:bodyPr/>
         <a:lstStyle/>

</xml_diff>